<commit_message>
chore(custom): snapshot production changes before v0.1.173
Source update operation: codex-guide-pdf-fix-v0.1.173-20260811T003637Z
</commit_message>
<xml_diff>
--- a/frontend/public/downloads/SynthAPI-产品使用手册-v0.1.173.pptx
+++ b/frontend/public/downloads/SynthAPI-产品使用手册-v0.1.173.pptx
@@ -5196,7 +5196,7 @@
       </p:grpSp>
       <p:grpSp>
         <p:nvGrpSpPr>
-          <p:cNvPr id="16" name="Group 16"/>
+          <p:cNvPr id="19" name="Group 19"/>
           <p:cNvGrpSpPr/>
           <p:nvPr/>
         </p:nvGrpSpPr>
@@ -5262,14 +5262,122 @@
         </p:pic>
         <p:sp>
           <p:nvSpPr>
-            <p:cNvPr id="10" name="Ellipse 10"/>
+            <p:cNvPr id="10" name="Freeform 10"/>
             <p:cNvSpPr/>
             <p:nvPr/>
           </p:nvSpPr>
           <p:spPr>
             <a:xfrm>
-              <a:off x="3000375" y="4162425"/>
-              <a:ext cx="419100" cy="419100"/>
+              <a:off x="3429000" y="4305300"/>
+              <a:ext cx="4019550" cy="9525"/>
+            </a:xfrm>
+            <a:custGeom>
+              <a:avLst/>
+              <a:gdLst/>
+              <a:ahLst/>
+              <a:cxnLst/>
+              <a:rect l="l" t="t" r="r" b="b"/>
+              <a:pathLst>
+                <a:path w="4019550" h="9525">
+                  <a:moveTo>
+                    <a:pt x="0" y="0"/>
+                  </a:moveTo>
+                  <a:lnTo>
+                    <a:pt x="4019550" y="0"/>
+                  </a:lnTo>
+                </a:path>
+              </a:pathLst>
+            </a:custGeom>
+            <a:noFill/>
+            <a:ln w="19050">
+              <a:solidFill>
+                <a:srgbClr val="E11D48"/>
+              </a:solidFill>
+            </a:ln>
+          </p:spPr>
+        </p:sp>
+        <p:sp>
+          <p:nvSpPr>
+            <p:cNvPr id="11" name="Freeform 11"/>
+            <p:cNvSpPr/>
+            <p:nvPr/>
+          </p:nvSpPr>
+          <p:spPr>
+            <a:xfrm>
+              <a:off x="3714750" y="5219700"/>
+              <a:ext cx="3733800" cy="9525"/>
+            </a:xfrm>
+            <a:custGeom>
+              <a:avLst/>
+              <a:gdLst/>
+              <a:ahLst/>
+              <a:cxnLst/>
+              <a:rect l="l" t="t" r="r" b="b"/>
+              <a:pathLst>
+                <a:path w="3733800" h="9525">
+                  <a:moveTo>
+                    <a:pt x="0" y="0"/>
+                  </a:moveTo>
+                  <a:lnTo>
+                    <a:pt x="3733800" y="0"/>
+                  </a:lnTo>
+                </a:path>
+              </a:pathLst>
+            </a:custGeom>
+            <a:noFill/>
+            <a:ln w="19050">
+              <a:solidFill>
+                <a:srgbClr val="E11D48"/>
+              </a:solidFill>
+            </a:ln>
+          </p:spPr>
+        </p:sp>
+        <p:sp>
+          <p:nvSpPr>
+            <p:cNvPr id="12" name="Freeform 12"/>
+            <p:cNvSpPr/>
+            <p:nvPr/>
+          </p:nvSpPr>
+          <p:spPr>
+            <a:xfrm>
+              <a:off x="3429000" y="5324475"/>
+              <a:ext cx="4019550" cy="314325"/>
+            </a:xfrm>
+            <a:custGeom>
+              <a:avLst/>
+              <a:gdLst/>
+              <a:ahLst/>
+              <a:cxnLst/>
+              <a:rect l="l" t="t" r="r" b="b"/>
+              <a:pathLst>
+                <a:path w="4019550" h="314325">
+                  <a:moveTo>
+                    <a:pt x="0" y="0"/>
+                  </a:moveTo>
+                  <a:lnTo>
+                    <a:pt x="4019550" y="314325"/>
+                  </a:lnTo>
+                </a:path>
+              </a:pathLst>
+            </a:custGeom>
+            <a:noFill/>
+            <a:ln w="19050">
+              <a:solidFill>
+                <a:srgbClr val="E11D48"/>
+              </a:solidFill>
+            </a:ln>
+          </p:spPr>
+        </p:sp>
+        <p:sp>
+          <p:nvSpPr>
+            <p:cNvPr id="13" name="Ellipse 13"/>
+            <p:cNvSpPr/>
+            <p:nvPr/>
+          </p:nvSpPr>
+          <p:spPr>
+            <a:xfrm>
+              <a:off x="7458075" y="4152900"/>
+              <a:ext cx="285750" cy="285750"/>
             </a:xfrm>
             <a:prstGeom prst="ellipse">
               <a:avLst/>
@@ -5277,21 +5385,23 @@
             <a:solidFill>
               <a:srgbClr val="E11D48"/>
             </a:solidFill>
-            <a:ln>
-              <a:noFill/>
-            </a:ln>
-          </p:spPr>
-        </p:sp>
-        <p:sp>
-          <p:nvSpPr>
-            <p:cNvPr id="11" name="TextBox 11"/>
+            <a:ln w="19050">
+              <a:solidFill>
+                <a:srgbClr val="FFFFFF"/>
+              </a:solidFill>
+            </a:ln>
+          </p:spPr>
+        </p:sp>
+        <p:sp>
+          <p:nvSpPr>
+            <p:cNvPr id="14" name="TextBox 14"/>
             <p:cNvSpPr txBox="1"/>
             <p:nvPr/>
           </p:nvSpPr>
           <p:spPr>
             <a:xfrm>
-              <a:off x="3143998" y="4286250"/>
-              <a:ext cx="131855" cy="293370"/>
+              <a:off x="7554801" y="4230052"/>
+              <a:ext cx="92298" cy="205359"/>
             </a:xfrm>
             <a:prstGeom prst="rect">
               <a:avLst/>
@@ -5309,7 +5419,7 @@
             <a:p>
               <a:pPr algn="ctr"/>
               <a:r>
-                <a:rPr lang="en-US" sz="1500" b="1" dirty="0">
+                <a:rPr lang="en-US" sz="1050" b="1" dirty="0">
                   <a:solidFill>
                     <a:srgbClr val="FFFFFF"/>
                   </a:solidFill>
@@ -5324,14 +5434,14 @@
         </p:sp>
         <p:sp>
           <p:nvSpPr>
-            <p:cNvPr id="12" name="Ellipse 12"/>
+            <p:cNvPr id="15" name="Ellipse 15"/>
             <p:cNvSpPr/>
             <p:nvPr/>
           </p:nvSpPr>
           <p:spPr>
             <a:xfrm>
-              <a:off x="3000375" y="4695825"/>
-              <a:ext cx="419100" cy="419100"/>
+              <a:off x="7458075" y="5076825"/>
+              <a:ext cx="285750" cy="285750"/>
             </a:xfrm>
             <a:prstGeom prst="ellipse">
               <a:avLst/>
@@ -5339,21 +5449,23 @@
             <a:solidFill>
               <a:srgbClr val="E11D48"/>
             </a:solidFill>
-            <a:ln>
-              <a:noFill/>
-            </a:ln>
-          </p:spPr>
-        </p:sp>
-        <p:sp>
-          <p:nvSpPr>
-            <p:cNvPr id="13" name="TextBox 13"/>
+            <a:ln w="19050">
+              <a:solidFill>
+                <a:srgbClr val="FFFFFF"/>
+              </a:solidFill>
+            </a:ln>
+          </p:spPr>
+        </p:sp>
+        <p:sp>
+          <p:nvSpPr>
+            <p:cNvPr id="16" name="TextBox 16"/>
             <p:cNvSpPr txBox="1"/>
             <p:nvPr/>
           </p:nvSpPr>
           <p:spPr>
             <a:xfrm>
-              <a:off x="3143998" y="4819650"/>
-              <a:ext cx="131855" cy="293370"/>
+              <a:off x="7554801" y="5153978"/>
+              <a:ext cx="92298" cy="205359"/>
             </a:xfrm>
             <a:prstGeom prst="rect">
               <a:avLst/>
@@ -5371,7 +5483,7 @@
             <a:p>
               <a:pPr algn="ctr"/>
               <a:r>
-                <a:rPr lang="en-US" sz="1500" b="1" dirty="0">
+                <a:rPr lang="en-US" sz="1050" b="1" dirty="0">
                   <a:solidFill>
                     <a:srgbClr val="FFFFFF"/>
                   </a:solidFill>
@@ -5386,14 +5498,14 @@
         </p:sp>
         <p:sp>
           <p:nvSpPr>
-            <p:cNvPr id="14" name="Ellipse 14"/>
+            <p:cNvPr id="17" name="Ellipse 17"/>
             <p:cNvSpPr/>
             <p:nvPr/>
           </p:nvSpPr>
           <p:spPr>
             <a:xfrm>
-              <a:off x="3000375" y="5238750"/>
-              <a:ext cx="419100" cy="419100"/>
+              <a:off x="7458075" y="5495925"/>
+              <a:ext cx="285750" cy="285750"/>
             </a:xfrm>
             <a:prstGeom prst="ellipse">
               <a:avLst/>
@@ -5401,21 +5513,23 @@
             <a:solidFill>
               <a:srgbClr val="E11D48"/>
             </a:solidFill>
-            <a:ln>
-              <a:noFill/>
-            </a:ln>
-          </p:spPr>
-        </p:sp>
-        <p:sp>
-          <p:nvSpPr>
-            <p:cNvPr id="15" name="TextBox 15"/>
+            <a:ln w="19050">
+              <a:solidFill>
+                <a:srgbClr val="FFFFFF"/>
+              </a:solidFill>
+            </a:ln>
+          </p:spPr>
+        </p:sp>
+        <p:sp>
+          <p:nvSpPr>
+            <p:cNvPr id="18" name="TextBox 18"/>
             <p:cNvSpPr txBox="1"/>
             <p:nvPr/>
           </p:nvSpPr>
           <p:spPr>
             <a:xfrm>
-              <a:off x="3143998" y="5362575"/>
-              <a:ext cx="131855" cy="293370"/>
+              <a:off x="7554801" y="5573078"/>
+              <a:ext cx="92298" cy="205359"/>
             </a:xfrm>
             <a:prstGeom prst="rect">
               <a:avLst/>
@@ -5433,7 +5547,7 @@
             <a:p>
               <a:pPr algn="ctr"/>
               <a:r>
-                <a:rPr lang="en-US" sz="1500" b="1" dirty="0">
+                <a:rPr lang="en-US" sz="1050" b="1" dirty="0">
                   <a:solidFill>
                     <a:srgbClr val="FFFFFF"/>
                   </a:solidFill>
@@ -5449,7 +5563,7 @@
       </p:grpSp>
       <p:grpSp>
         <p:nvGrpSpPr>
-          <p:cNvPr id="32" name="Group 32"/>
+          <p:cNvPr id="35" name="Group 35"/>
           <p:cNvGrpSpPr/>
           <p:nvPr/>
         </p:nvGrpSpPr>
@@ -5463,7 +5577,7 @@
         </p:grpSpPr>
         <p:sp>
           <p:nvSpPr>
-            <p:cNvPr id="17" name="Rectangle 17"/>
+            <p:cNvPr id="20" name="Rectangle 20"/>
             <p:cNvSpPr/>
             <p:nvPr/>
           </p:nvSpPr>
@@ -5487,7 +5601,7 @@
         </p:sp>
         <p:sp>
           <p:nvSpPr>
-            <p:cNvPr id="18" name="Ellipse 18"/>
+            <p:cNvPr id="21" name="Ellipse 21"/>
             <p:cNvSpPr/>
             <p:nvPr/>
           </p:nvSpPr>
@@ -5509,7 +5623,7 @@
         </p:sp>
         <p:sp>
           <p:nvSpPr>
-            <p:cNvPr id="19" name="TextBox 19"/>
+            <p:cNvPr id="22" name="TextBox 22"/>
             <p:cNvSpPr txBox="1"/>
             <p:nvPr/>
           </p:nvSpPr>
@@ -5549,7 +5663,7 @@
         </p:sp>
         <p:sp>
           <p:nvSpPr>
-            <p:cNvPr id="20" name="TextBox 20"/>
+            <p:cNvPr id="23" name="TextBox 23"/>
             <p:cNvSpPr txBox="1"/>
             <p:nvPr/>
           </p:nvSpPr>
@@ -5589,7 +5703,7 @@
         </p:sp>
         <p:sp>
           <p:nvSpPr>
-            <p:cNvPr id="21" name="TextBox 21"/>
+            <p:cNvPr id="24" name="TextBox 24"/>
             <p:cNvSpPr txBox="1"/>
             <p:nvPr/>
           </p:nvSpPr>
@@ -5642,7 +5756,7 @@
         </p:sp>
         <p:sp>
           <p:nvSpPr>
-            <p:cNvPr id="22" name="Rectangle 22"/>
+            <p:cNvPr id="25" name="Rectangle 25"/>
             <p:cNvSpPr/>
             <p:nvPr/>
           </p:nvSpPr>
@@ -5666,7 +5780,7 @@
         </p:sp>
         <p:sp>
           <p:nvSpPr>
-            <p:cNvPr id="23" name="Ellipse 23"/>
+            <p:cNvPr id="26" name="Ellipse 26"/>
             <p:cNvSpPr/>
             <p:nvPr/>
           </p:nvSpPr>
@@ -5688,7 +5802,7 @@
         </p:sp>
         <p:sp>
           <p:nvSpPr>
-            <p:cNvPr id="24" name="TextBox 24"/>
+            <p:cNvPr id="27" name="TextBox 27"/>
             <p:cNvSpPr txBox="1"/>
             <p:nvPr/>
           </p:nvSpPr>
@@ -5728,7 +5842,7 @@
         </p:sp>
         <p:sp>
           <p:nvSpPr>
-            <p:cNvPr id="25" name="TextBox 25"/>
+            <p:cNvPr id="28" name="TextBox 28"/>
             <p:cNvSpPr txBox="1"/>
             <p:nvPr/>
           </p:nvSpPr>
@@ -5768,7 +5882,7 @@
         </p:sp>
         <p:sp>
           <p:nvSpPr>
-            <p:cNvPr id="26" name="TextBox 26"/>
+            <p:cNvPr id="29" name="TextBox 29"/>
             <p:cNvSpPr txBox="1"/>
             <p:nvPr/>
           </p:nvSpPr>
@@ -5821,7 +5935,7 @@
         </p:sp>
         <p:sp>
           <p:nvSpPr>
-            <p:cNvPr id="27" name="Rectangle 27"/>
+            <p:cNvPr id="30" name="Rectangle 30"/>
             <p:cNvSpPr/>
             <p:nvPr/>
           </p:nvSpPr>
@@ -5845,7 +5959,7 @@
         </p:sp>
         <p:sp>
           <p:nvSpPr>
-            <p:cNvPr id="28" name="Ellipse 28"/>
+            <p:cNvPr id="31" name="Ellipse 31"/>
             <p:cNvSpPr/>
             <p:nvPr/>
           </p:nvSpPr>
@@ -5867,7 +5981,7 @@
         </p:sp>
         <p:sp>
           <p:nvSpPr>
-            <p:cNvPr id="29" name="TextBox 29"/>
+            <p:cNvPr id="32" name="TextBox 32"/>
             <p:cNvSpPr txBox="1"/>
             <p:nvPr/>
           </p:nvSpPr>
@@ -5907,7 +6021,7 @@
         </p:sp>
         <p:sp>
           <p:nvSpPr>
-            <p:cNvPr id="30" name="TextBox 30"/>
+            <p:cNvPr id="33" name="TextBox 33"/>
             <p:cNvSpPr txBox="1"/>
             <p:nvPr/>
           </p:nvSpPr>
@@ -5947,7 +6061,7 @@
         </p:sp>
         <p:sp>
           <p:nvSpPr>
-            <p:cNvPr id="31" name="TextBox 31"/>
+            <p:cNvPr id="34" name="TextBox 34"/>
             <p:cNvSpPr txBox="1"/>
             <p:nvPr/>
           </p:nvSpPr>
@@ -6001,7 +6115,7 @@
       </p:grpSp>
       <p:grpSp>
         <p:nvGrpSpPr>
-          <p:cNvPr id="35" name="Group 35"/>
+          <p:cNvPr id="38" name="Group 38"/>
           <p:cNvGrpSpPr/>
           <p:nvPr/>
         </p:nvGrpSpPr>
@@ -6015,7 +6129,7 @@
         </p:grpSpPr>
         <p:sp>
           <p:nvSpPr>
-            <p:cNvPr id="33" name="Rectangle 33"/>
+            <p:cNvPr id="36" name="Rectangle 36"/>
             <p:cNvSpPr/>
             <p:nvPr/>
           </p:nvSpPr>
@@ -6039,7 +6153,7 @@
         </p:sp>
         <p:sp>
           <p:nvSpPr>
-            <p:cNvPr id="34" name="TextBox 34"/>
+            <p:cNvPr id="37" name="TextBox 37"/>
             <p:cNvSpPr txBox="1"/>
             <p:nvPr/>
           </p:nvSpPr>
@@ -6080,7 +6194,7 @@
       </p:grpSp>
       <p:grpSp>
         <p:nvGrpSpPr>
-          <p:cNvPr id="38" name="Group 38"/>
+          <p:cNvPr id="41" name="Group 41"/>
           <p:cNvGrpSpPr/>
           <p:nvPr/>
         </p:nvGrpSpPr>
@@ -6094,7 +6208,7 @@
         </p:grpSpPr>
         <p:sp>
           <p:nvSpPr>
-            <p:cNvPr id="36" name="TextBox 36"/>
+            <p:cNvPr id="39" name="TextBox 39"/>
             <p:cNvSpPr txBox="1"/>
             <p:nvPr/>
           </p:nvSpPr>
@@ -6134,7 +6248,7 @@
         </p:sp>
         <p:sp>
           <p:nvSpPr>
-            <p:cNvPr id="37" name="TextBox 37"/>
+            <p:cNvPr id="40" name="TextBox 40"/>
             <p:cNvSpPr txBox="1"/>
             <p:nvPr/>
           </p:nvSpPr>

</xml_diff>